<commit_message>
feat: harden Document AI labs for live delivery
</commit_message>
<xml_diff>
--- a/sample_docs/formats/table_summary.pptx
+++ b/sample_docs/formats/table_summary.pptx
@@ -2,13 +2,13 @@
 <file path=ppt/presentation.xml><?xml version="1.0" encoding="utf-8"?>
 <p:presentation xmlns:p="http://schemas.openxmlformats.org/presentationml/2006/main">
   <p:sldMasterIdLst>
-    <p:sldMasterId xmlns:r="http://schemas.openxmlformats.org/officeDocument/2006/relationships" id="2147483648" r:id="R30d2f527e6d344d0"/>
+    <p:sldMasterId xmlns:r="http://schemas.openxmlformats.org/officeDocument/2006/relationships" id="2147483648" r:id="Rea215a15ae174949"/>
   </p:sldMasterIdLst>
   <p:notesMasterIdLst>
-    <p:notesMasterId xmlns:r="http://schemas.openxmlformats.org/officeDocument/2006/relationships" r:id="Rea5a6ec3612545a1"/>
+    <p:notesMasterId xmlns:r="http://schemas.openxmlformats.org/officeDocument/2006/relationships" r:id="R35d90ee990e64a65"/>
   </p:notesMasterIdLst>
   <p:sldIdLst>
-    <p:sldId xmlns:r="http://schemas.openxmlformats.org/officeDocument/2006/relationships" id="256" r:id="Rce9085ef07a04caf"/>
+    <p:sldId xmlns:r="http://schemas.openxmlformats.org/officeDocument/2006/relationships" id="256" r:id="R21efd1103bfa43c3"/>
   </p:sldIdLst>
   <p:sldSz cx="12192000" cy="6858000"/>
   <p:notesSz cx="6858000" cy="9144000"/>
@@ -506,7 +506,7 @@
   </p:cSld>
   <p:clrMap bg1="lt1" tx1="dk1" bg2="lt2" tx2="dk2" accent1="accent1" accent2="accent2" accent3="accent3" accent4="accent4" accent5="accent5" accent6="accent6" hlink="hlink" folHlink="folHlink"/>
   <p:sldLayoutIdLst>
-    <p:sldLayoutId xmlns:r="http://schemas.openxmlformats.org/officeDocument/2006/relationships" id="2147483649" r:id="R52a6712c377f4294"/>
+    <p:sldLayoutId xmlns:r="http://schemas.openxmlformats.org/officeDocument/2006/relationships" id="2147483649" r:id="R14ce2199965f4bfe"/>
   </p:sldLayoutIdLst>
   <p:txStyles>
     <p:titleStyle>
@@ -1085,6 +1085,7 @@
           <a:lstStyle xmlns:a="http://schemas.openxmlformats.org/drawingml/2006/main"/>
           <a:p xmlns:a="http://schemas.openxmlformats.org/drawingml/2006/main">
             <a:pPr>
+              <a:buNone/>
               <a:defRPr sz="3000" b="1">
                 <a:solidFill>
                   <a:srgbClr val="173B57"/>
@@ -1096,6 +1097,9 @@
                 <a:solidFill>
                   <a:srgbClr val="173B57"/>
                 </a:solidFill>
+                <a:latin typeface="Arial Unicode MS"/>
+                <a:ea typeface="Arial Unicode MS"/>
+                <a:cs typeface="Arial Unicode MS"/>
               </a:rPr>
               <a:t>표 캡처는 ‘셀’이 아니라 ‘픽셀’입니다</a:t>
             </a:r>
@@ -1135,6 +1139,7 @@
           <a:lstStyle xmlns:a="http://schemas.openxmlformats.org/drawingml/2006/main"/>
           <a:p xmlns:a="http://schemas.openxmlformats.org/drawingml/2006/main">
             <a:pPr>
+              <a:buNone/>
               <a:defRPr sz="1575">
                 <a:solidFill>
                   <a:srgbClr val="475467"/>
@@ -1146,6 +1151,9 @@
                 <a:solidFill>
                   <a:srgbClr val="475467"/>
                 </a:solidFill>
+                <a:latin typeface="Arial Unicode MS"/>
+                <a:ea typeface="Arial Unicode MS"/>
+                <a:cs typeface="Arial Unicode MS"/>
               </a:rPr>
               <a:t>행·열·병합 구조를 다시 복원해야 Excel로 안전하게 돌아갑니다.</a:t>
             </a:r>
@@ -1154,14 +1162,14 @@
       </p:sp>
       <p:pic>
         <p:nvPicPr>
-          <p:cNvPr id="10" name=""/>
+          <p:cNvPr id="12" name=""/>
           <p:cNvPicPr>
             <a:picLocks xmlns:a="http://schemas.openxmlformats.org/drawingml/2006/main" noChangeAspect="1"/>
           </p:cNvPicPr>
           <p:nvPr/>
         </p:nvPicPr>
         <p:blipFill>
-          <a:blip xmlns:r="http://schemas.openxmlformats.org/officeDocument/2006/relationships" xmlns:a="http://schemas.openxmlformats.org/drawingml/2006/main" r:embed="Rd3d29785f0844e7b"/>
+          <a:blip xmlns:r="http://schemas.openxmlformats.org/officeDocument/2006/relationships" xmlns:a="http://schemas.openxmlformats.org/drawingml/2006/main" r:embed="R214435900fbe4a5d"/>
           <a:srcRect xmlns:a="http://schemas.openxmlformats.org/drawingml/2006/main" l="0" t="15841" r="0" b="15841"/>
           <a:stretch xmlns:a="http://schemas.openxmlformats.org/drawingml/2006/main">
             <a:fillRect l="0" t="0" r="0" b="0"/>
@@ -1212,6 +1220,7 @@
           <a:lstStyle xmlns:a="http://schemas.openxmlformats.org/drawingml/2006/main"/>
           <a:p xmlns:a="http://schemas.openxmlformats.org/drawingml/2006/main">
             <a:pPr>
+              <a:buNone/>
               <a:defRPr sz="2025" b="1">
                 <a:solidFill>
                   <a:srgbClr val="0F766E"/>
@@ -1223,6 +1232,9 @@
                 <a:solidFill>
                   <a:srgbClr val="0F766E"/>
                 </a:solidFill>
+                <a:latin typeface="Arial Unicode MS"/>
+                <a:ea typeface="Arial Unicode MS"/>
+                <a:cs typeface="Arial Unicode MS"/>
               </a:rPr>
               <a:t>자동화 전에 복원할 것</a:t>
             </a:r>
@@ -1262,6 +1274,7 @@
           <a:lstStyle xmlns:a="http://schemas.openxmlformats.org/drawingml/2006/main"/>
           <a:p xmlns:a="http://schemas.openxmlformats.org/drawingml/2006/main">
             <a:pPr>
+              <a:buNone/>
               <a:defRPr sz="1725">
                 <a:solidFill>
                   <a:srgbClr val="1D2939"/>
@@ -1273,12 +1286,16 @@
                 <a:solidFill>
                   <a:srgbClr val="1D2939"/>
                 </a:solidFill>
+                <a:latin typeface="Arial Unicode MS"/>
+                <a:ea typeface="Arial Unicode MS"/>
+                <a:cs typeface="Arial Unicode MS"/>
               </a:rPr>
               <a:t>1. 품목 행의 시작과 끝</a:t>
             </a:r>
           </a:p>
           <a:p xmlns:a="http://schemas.openxmlformats.org/drawingml/2006/main">
             <a:pPr>
+              <a:buNone/>
               <a:defRPr sz="1725">
                 <a:solidFill>
                   <a:srgbClr val="1D2939"/>
@@ -1290,12 +1307,16 @@
                 <a:solidFill>
                   <a:srgbClr val="1D2939"/>
                 </a:solidFill>
+                <a:latin typeface="Arial Unicode MS"/>
+                <a:ea typeface="Arial Unicode MS"/>
+                <a:cs typeface="Arial Unicode MS"/>
               </a:rPr>
               <a:t>2. 수량·단가·금액의 열 대응</a:t>
             </a:r>
           </a:p>
           <a:p xmlns:a="http://schemas.openxmlformats.org/drawingml/2006/main">
             <a:pPr>
+              <a:buNone/>
               <a:defRPr sz="1725">
                 <a:solidFill>
                   <a:srgbClr val="1D2939"/>
@@ -1307,12 +1328,16 @@
                 <a:solidFill>
                   <a:srgbClr val="1D2939"/>
                 </a:solidFill>
+                <a:latin typeface="Arial Unicode MS"/>
+                <a:ea typeface="Arial Unicode MS"/>
+                <a:cs typeface="Arial Unicode MS"/>
               </a:rPr>
               <a:t>3. 품목 소계와 세액·총액 관계</a:t>
             </a:r>
           </a:p>
           <a:p xmlns:a="http://schemas.openxmlformats.org/drawingml/2006/main">
             <a:pPr>
+              <a:buNone/>
               <a:defRPr sz="1725">
                 <a:solidFill>
                   <a:srgbClr val="1D2939"/>
@@ -1324,6 +1349,9 @@
                 <a:solidFill>
                   <a:srgbClr val="1D2939"/>
                 </a:solidFill>
+                <a:latin typeface="Arial Unicode MS"/>
+                <a:ea typeface="Arial Unicode MS"/>
+                <a:cs typeface="Arial Unicode MS"/>
               </a:rPr>
               <a:t>4. 원본 위치와 최종 셀의 근거</a:t>
             </a:r>
@@ -1335,6 +1363,7 @@
           </a:p>
           <a:p xmlns:a="http://schemas.openxmlformats.org/drawingml/2006/main">
             <a:pPr>
+              <a:buNone/>
               <a:defRPr sz="1725">
                 <a:solidFill>
                   <a:srgbClr val="1D2939"/>
@@ -1346,6 +1375,9 @@
                 <a:solidFill>
                   <a:srgbClr val="1D2939"/>
                 </a:solidFill>
+                <a:latin typeface="Arial Unicode MS"/>
+                <a:ea typeface="Arial Unicode MS"/>
+                <a:cs typeface="Arial Unicode MS"/>
               </a:rPr>
               <a:t>문서가 PPT라면 그룹 도형, 읽기 순서, 발표자 노트까지 별도로 확인합니다.</a:t>
             </a:r>
@@ -1385,6 +1417,7 @@
           <a:lstStyle xmlns:a="http://schemas.openxmlformats.org/drawingml/2006/main"/>
           <a:p xmlns:a="http://schemas.openxmlformats.org/drawingml/2006/main">
             <a:pPr>
+              <a:buNone/>
               <a:defRPr sz="1350" b="1">
                 <a:solidFill>
                   <a:srgbClr val="7A5A00"/>
@@ -1396,6 +1429,9 @@
                 <a:solidFill>
                   <a:srgbClr val="7A5A00"/>
                 </a:solidFill>
+                <a:latin typeface="Arial Unicode MS"/>
+                <a:ea typeface="Arial Unicode MS"/>
+                <a:cs typeface="Arial Unicode MS"/>
               </a:rPr>
               <a:t>실습: 이 슬라이드를 이미지로 캡처한 뒤, 표 구조가 얼마나 사라지는지 비교해 보세요.</a:t>
             </a:r>
@@ -1435,6 +1471,7 @@
           <a:lstStyle xmlns:a="http://schemas.openxmlformats.org/drawingml/2006/main"/>
           <a:p xmlns:a="http://schemas.openxmlformats.org/drawingml/2006/main">
             <a:pPr>
+              <a:buNone/>
               <a:defRPr sz="975">
                 <a:solidFill>
                   <a:srgbClr val="667085"/>
@@ -1446,6 +1483,9 @@
                 <a:solidFill>
                   <a:srgbClr val="667085"/>
                 </a:solidFill>
+                <a:latin typeface="Arial Unicode MS"/>
+                <a:ea typeface="Arial Unicode MS"/>
+                <a:cs typeface="Arial Unicode MS"/>
               </a:rPr>
               <a:t>교육용 합성 문서 · 실제 개인정보 없음</a:t>
             </a:r>

</xml_diff>